<commit_message>
Final submission: demo video link, deck and README
</commit_message>
<xml_diff>
--- a/docs/SRMIST_QueueQueueing.pptx
+++ b/docs/SRMIST_QueueQueueing.pptx
@@ -14660,7 +14660,7 @@
                 <a:cs typeface="Calibri"/>
                 <a:sym typeface="Calibri"/>
               </a:rPr>
-              <a:t>Demo video, max 5 minutes: link in README (YouTube, unlisted)</a:t>
+              <a:t>Demo video, max 5 minutes: https://drive.google.com/drive/folders/1ATDX614AjhvJfmq3afcTFr0g-L0GjvHL?usp=drive_link</a:t>
             </a:r>
             <a:endParaRPr sz="2800"/>
           </a:p>
@@ -20076,7 +20076,7 @@
                 </a:solidFill>
                 <a:latin typeface="Calibri"/>
               </a:rPr>
-              <a:t>link in README (YouTube, unlisted)</a:t>
+              <a:t>https://drive.google.com/drive/folders/1ATDX614AjhvJfmq3afcTFr0g-L0GjvHL?usp=drive_link</a:t>
             </a:r>
           </a:p>
         </p:txBody>

</xml_diff>

<commit_message>
Tier 1+2 update: cache specificity, bug fixes, LLM judge, full-LLM ablation, final held-out sets, refreshed docs
</commit_message>
<xml_diff>
--- a/docs/SRMIST_QueueQueueing.pptx
+++ b/docs/SRMIST_QueueQueueing.pptx
@@ -325,7 +325,7 @@
                 <c:formatCode>General</c:formatCode>
                 <c:ptCount val="2"/>
                 <c:pt idx="0">
-                  <c:v>1.76</c:v>
+                  <c:v>1.88</c:v>
                 </c:pt>
                 <c:pt idx="1">
                   <c:v>1.0</c:v>
@@ -340,6 +340,55 @@
           <c:tx>
             <c:strRef>
               <c:f>Sheet1!$C$1</c:f>
+              <c:strCache>
+                <c:ptCount val="1"/>
+                <c:pt idx="0">
+                  <c:v>Full-LLM mapping</c:v>
+                </c:pt>
+              </c:strCache>
+            </c:strRef>
+          </c:tx>
+          <c:spPr>
+            <a:solidFill>
+              <a:srgbClr val="C77700"/>
+            </a:solidFill>
+          </c:spPr>
+          <c:cat>
+            <c:strRef>
+              <c:f>Sheet1!$A$2:$A$3</c:f>
+              <c:strCache>
+                <c:ptCount val="2"/>
+                <c:pt idx="0">
+                  <c:v>Deeplink relevance (0–2)</c:v>
+                </c:pt>
+                <c:pt idx="1">
+                  <c:v>Link precision (0–1)</c:v>
+                </c:pt>
+              </c:strCache>
+            </c:strRef>
+          </c:cat>
+          <c:val>
+            <c:numRef>
+              <c:f>Sheet1!$C$2:$C$3</c:f>
+              <c:numCache>
+                <c:formatCode>General</c:formatCode>
+                <c:ptCount val="2"/>
+                <c:pt idx="0">
+                  <c:v>1.76</c:v>
+                </c:pt>
+                <c:pt idx="1">
+                  <c:v>0.75</c:v>
+                </c:pt>
+              </c:numCache>
+            </c:numRef>
+          </c:val>
+        </c:ser>
+        <c:ser>
+          <c:idx val="2"/>
+          <c:order val="2"/>
+          <c:tx>
+            <c:strRef>
+              <c:f>Sheet1!$D$1</c:f>
               <c:strCache>
                 <c:ptCount val="1"/>
                 <c:pt idx="0">
@@ -369,7 +418,7 @@
           </c:cat>
           <c:val>
             <c:numRef>
-              <c:f>Sheet1!$C$2:$C$3</c:f>
+              <c:f>Sheet1!$D$2:$D$3</c:f>
               <c:numCache>
                 <c:formatCode>General</c:formatCode>
                 <c:ptCount val="2"/>
@@ -2578,7 +2627,7 @@
           </a:p>
           <a:p>
             <a:r>
-              <a:t>CPU-only stack; runs with or without an API key. Point out the official schema is imported unchanged and 47 tests guard every contract rule.</a:t>
+              <a:t>CPU-only stack; runs with or without an API key. Point out the official schema is imported unchanged and 53 tests guard every contract rule.</a:t>
             </a:r>
           </a:p>
         </p:txBody>
@@ -13814,7 +13863,7 @@
                 </a:solidFill>
                 <a:latin typeface="Calibri"/>
               </a:rPr>
-              <a:t>Held-out paraphrases, 4-domain scenarios, gold labels, and a scripted 3-way ablation, with honest limits.</a:t>
+              <a:t>Two held-out scenario sets, three paraphrase sets, gold labels, an LLM judge and a 3-way ablation, with honest limits.</a:t>
             </a:r>
           </a:p>
         </p:txBody>
@@ -14252,7 +14301,7 @@
                 </a:solidFill>
                 <a:latin typeface="Calibri"/>
               </a:rPr>
-              <a:t>Official schema unchanged, every rule enforced in code, brand-neutral outputs, 47 hermetic tests.</a:t>
+              <a:t>Official schema unchanged, every rule enforced in code, brand-neutral outputs, 53 hermetic tests.</a:t>
             </a:r>
           </a:p>
         </p:txBody>
@@ -14455,7 +14504,7 @@
                 </a:solidFill>
                 <a:latin typeface="Calibri"/>
               </a:rPr>
-              <a:t>Full-LLM mapping baseline implemented (eval/ablation.py); not completed due to the provider outage.</a:t>
+              <a:t>D1 + D2 scored on gold (eval/ablation.py). Full-LLM mapping also costs $0.00125 per query and 6 s P95; ours is $0.</a:t>
             </a:r>
           </a:p>
         </p:txBody>
@@ -21317,7 +21366,7 @@
                 </a:solidFill>
                 <a:latin typeface="Calibri"/>
               </a:rPr>
-              <a:t>pytest (47 hermetic tests) · evaluation harness · ablation · gold labels</a:t>
+              <a:t>pytest (53 hermetic tests) · eval harness · LLM judge · ablation · gold labels</a:t>
             </a:r>
           </a:p>
         </p:txBody>
@@ -23114,7 +23163,7 @@
                 </a:solidFill>
                 <a:latin typeface="Calibri"/>
               </a:rPr>
-              <a:t>Gates 100%: schema, rules, 0 URL leaks, catalog-valid links (D1 + D2)</a:t>
+              <a:t>Gates 100%: schema, rules, 0 URL leaks, catalog-valid links (official + 2 held-out sets)</a:t>
             </a:r>
           </a:p>
           <a:p>
@@ -23131,7 +23180,7 @@
                 </a:solidFill>
                 <a:latin typeface="Calibri"/>
               </a:rPr>
-              <a:t>Deeplink precision 100%; relevance 2.00 (D1) / 1.71 (D2) of 2</a:t>
+              <a:t>Step accuracy 2.60 official / 2.73 final held-out (of 3); LLM judge 1.94 / 2.06</a:t>
             </a:r>
           </a:p>
           <a:p>
@@ -23148,7 +23197,7 @@
                 </a:solidFill>
                 <a:latin typeface="Calibri"/>
               </a:rPr>
-              <a:t>Step-accuracy proxy 2.20 (D1) / 2.88 (D2) of 3; abstention 90% / 100%</a:t>
+              <a:t>Deeplink relevance 2.00 / 1.82 of 2; abstention 95% / 90%</a:t>
             </a:r>
           </a:p>
           <a:p>
@@ -23165,7 +23214,7 @@
                 </a:solidFill>
                 <a:latin typeface="Calibri"/>
               </a:rPr>
-              <a:t>Cache P95: 0 ms exact, 48 ms unseen paraphrase; 81.8% hit</a:t>
+              <a:t>Unseen paraphrases: 87.5% same plan, 0 false hits, P95 82 ms</a:t>
             </a:r>
           </a:p>
           <a:p>
@@ -23182,7 +23231,7 @@
                 </a:solidFill>
                 <a:latin typeface="Calibri"/>
               </a:rPr>
-              <a:t>Ablation: hybrid 1.76 rel / 100% precision vs rules 1.29 / 58%</a:t>
+              <a:t>Ablation: hybrid 1.88 rel / 100% precision vs full-LLM 1.76 / 75%, rules 1.29 / 58%</a:t>
             </a:r>
           </a:p>
         </p:txBody>
@@ -23305,7 +23354,7 @@
                 </a:solidFill>
                 <a:latin typeface="Calibri"/>
               </a:rPr>
-              <a:t>Provider outage: the LLM built 12 of 20 official plans; the rest used rules</a:t>
+              <a:t>Final never-tuned paraphrase set: 75% hit (target 80%)</a:t>
             </a:r>
           </a:p>
           <a:p>
@@ -23322,7 +23371,7 @@
                 </a:solidFill>
                 <a:latin typeface="Calibri"/>
               </a:rPr>
-              <a:t>Paraphrases: every hit had the right symptom; 59% the exact same article</a:t>
+              <a:t>LLM sometimes drops an article section; compiles vary run to run</a:t>
             </a:r>
           </a:p>
           <a:p>
@@ -23339,7 +23388,7 @@
                 </a:solidFill>
                 <a:latin typeface="Calibri"/>
               </a:rPr>
-              <a:t>Offline relevance is coarse; LLM sometimes drops a section</a:t>
+              <a:t>The LLM judge is noisy; gold labels by one annotator</a:t>
             </a:r>
           </a:p>
           <a:p>
@@ -23356,7 +23405,7 @@
                 </a:solidFill>
                 <a:latin typeface="Calibri"/>
               </a:rPr>
-              <a:t>Gold labels by one annotator; D2 used once for error analysis</a:t>
+              <a:t>Offline relevance is coarse (one official line abstains)</a:t>
             </a:r>
           </a:p>
           <a:p>

</xml_diff>